<commit_message>
Update Week 2 lecture slides
Refreshes the Week 2 Lecture 4 slide deck by updating both the PDF and PowerPoint source files for the course materials.
</commit_message>
<xml_diff>
--- a/docs/lecture_slides/Week 2/Week2_Lecture4_slides_1_19_2024.pptx
+++ b/docs/lecture_slides/Week 2/Week2_Lecture4_slides_1_19_2024.pptx
@@ -3803,6 +3803,45 @@
           </a:extLst>
         </p:spPr>
       </p:pic>
+      <p:sp>
+        <p:nvSpPr>
+          <p:cNvPr id="4" name="Dataset note">
+            <a:extLst>
+              <a:ext uri="{FF2B5EF4-FFF2-40B4-BE49-F238E27FC236}">
+                <a16:creationId xmlns:a16="http://schemas.microsoft.com/office/drawing/2014/main" id="{1F2F0356-28C4-0A6D-B88E-3707F5009C99}"/>
+              </a:ext>
+            </a:extLst>
+          </p:cNvPr>
+          <p:cNvSpPr txBox="1"/>
+          <p:nvPr/>
+        </p:nvSpPr>
+        <p:spPr>
+          <a:xfrm>
+            <a:off x="266700" y="6096000"/>
+            <a:ext cx="11798300" cy="646331"/>
+          </a:xfrm>
+          <a:prstGeom prst="rect">
+            <a:avLst/>
+          </a:prstGeom>
+          <a:noFill/>
+        </p:spPr>
+        <p:txBody>
+          <a:bodyPr vert="horz" wrap="square" rtlCol="0">
+            <a:spAutoFit/>
+          </a:bodyPr>
+          <a:lstStyle/>
+          <a:p>
+            <a:r>
+              <a:rPr lang="en-US" sz="1200" b="1"/>
+              <a:t>About the data:</a:t>
+            </a:r>
+            <a:r>
+              <a:rPr lang="en-US" sz="1200"/>
+              <a:t> mtcars – road-test figures for 32 cars from the 1974 Motor Trend US magazine (1973–74 models), one row per car. We use two of its 11 variables: mpg (miles per US gallon, ranging 10.4 to 33.9) and cyl, the number of engine cylinders – 4, 6 or 8, with 11, 7 and 14 cars in each group. Cylinder count is a grouping variable, which is what lets the dot plot on the next slide compare three groups side by side.</a:t>
+            </a:r>
+          </a:p>
+        </p:txBody>
+      </p:sp>
     </p:spTree>
     <p:extLst>
       <p:ext uri="{BB962C8B-B14F-4D97-AF65-F5344CB8AC3E}">

</xml_diff>

<commit_message>
Add Lecture 5 review materials
Adds the Week 2 Lecture 5 slide links and generated review figures, and refreshes the lecture menus to cover descriptive statistics, percentiles, and spread. Rebuilt the affected site pages and PDFs so the published docs match the updated content.
</commit_message>
<xml_diff>
--- a/docs/lecture_slides/Week 2/Week2_Lecture4_slides_1_19_2024.pptx
+++ b/docs/lecture_slides/Week 2/Week2_Lecture4_slides_1_19_2024.pptx
@@ -27,20 +27,19 @@
     <p:sldId id="328" r:id="rId21"/>
     <p:sldId id="332" r:id="rId22"/>
     <p:sldId id="295" r:id="rId23"/>
-    <p:sldId id="294" r:id="rId24"/>
-    <p:sldId id="338" r:id="rId25"/>
-    <p:sldId id="341" r:id="rId26"/>
-    <p:sldId id="304" r:id="rId27"/>
-    <p:sldId id="330" r:id="rId28"/>
-    <p:sldId id="307" r:id="rId29"/>
-    <p:sldId id="342" r:id="rId30"/>
-    <p:sldId id="305" r:id="rId31"/>
-    <p:sldId id="343" r:id="rId32"/>
-    <p:sldId id="344" r:id="rId33"/>
-    <p:sldId id="345" r:id="rId34"/>
-    <p:sldId id="346" r:id="rId35"/>
-    <p:sldId id="309" r:id="rId36"/>
-    <p:sldId id="308" r:id="rId37"/>
+    <p:sldId id="338" r:id="rId24"/>
+    <p:sldId id="341" r:id="rId25"/>
+    <p:sldId id="304" r:id="rId26"/>
+    <p:sldId id="330" r:id="rId27"/>
+    <p:sldId id="307" r:id="rId28"/>
+    <p:sldId id="342" r:id="rId29"/>
+    <p:sldId id="305" r:id="rId30"/>
+    <p:sldId id="343" r:id="rId31"/>
+    <p:sldId id="344" r:id="rId32"/>
+    <p:sldId id="345" r:id="rId33"/>
+    <p:sldId id="346" r:id="rId34"/>
+    <p:sldId id="309" r:id="rId35"/>
+    <p:sldId id="308" r:id="rId36"/>
   </p:sldIdLst>
   <p:sldSz cx="12192000" cy="6858000"/>
   <p:notesSz cx="6858000" cy="9144000"/>
@@ -9351,102 +9350,12 @@
           <a:chExt cx="0" cy="0"/>
         </a:xfrm>
       </p:grpSpPr>
-      <p:pic>
-        <p:nvPicPr>
-          <p:cNvPr id="4" name="Picture 3" descr="Frequency table of Old Faithful waiting times in ten-minute bins with frequency, relative frequency and cumulative relative frequency.">
-            <a:extLst>
-              <a:ext uri="{FF2B5EF4-FFF2-40B4-BE49-F238E27FC236}">
-                <a16:creationId xmlns:a16="http://schemas.microsoft.com/office/drawing/2014/main" id="{43F76311-3A9D-2395-F921-58D84AC2F9B4}"/>
-              </a:ext>
-            </a:extLst>
-          </p:cNvPr>
-          <p:cNvPicPr>
-            <a:picLocks noChangeAspect="1"/>
-          </p:cNvPicPr>
-          <p:nvPr/>
-        </p:nvPicPr>
-        <p:blipFill>
-          <a:blip r:embed="rId2"/>
-          <a:stretch>
-            <a:fillRect/>
-          </a:stretch>
-        </p:blipFill>
-        <p:spPr>
-          <a:xfrm>
-            <a:off x="406043" y="2371724"/>
-            <a:ext cx="5299432" cy="2512843"/>
-          </a:xfrm>
-          <a:prstGeom prst="rect">
-            <a:avLst/>
-          </a:prstGeom>
-        </p:spPr>
-      </p:pic>
-      <p:pic>
-        <p:nvPicPr>
-          <p:cNvPr id="10" name="Picture 9" descr="Histogram of Old Faithful waiting times in ten-minute bins, frequency on the vertical axis, showing two peaks either side of a dip near 65 minutes.">
-            <a:extLst>
-              <a:ext uri="{FF2B5EF4-FFF2-40B4-BE49-F238E27FC236}">
-                <a16:creationId xmlns:a16="http://schemas.microsoft.com/office/drawing/2014/main" id="{9AC59B7A-4888-2F53-4913-9DA0E60378A7}"/>
-              </a:ext>
-            </a:extLst>
-          </p:cNvPr>
-          <p:cNvPicPr>
-            <a:picLocks noChangeAspect="1"/>
-          </p:cNvPicPr>
-          <p:nvPr/>
-        </p:nvPicPr>
-        <p:blipFill>
-          <a:blip r:embed="rId3"/>
-          <a:stretch>
-            <a:fillRect/>
-          </a:stretch>
-        </p:blipFill>
-        <p:spPr>
-          <a:xfrm>
-            <a:off x="6096000" y="3428176"/>
-            <a:ext cx="5972175" cy="3429824"/>
-          </a:xfrm>
-          <a:prstGeom prst="rect">
-            <a:avLst/>
-          </a:prstGeom>
-        </p:spPr>
-      </p:pic>
-      <p:pic>
-        <p:nvPicPr>
-          <p:cNvPr id="8" name="Picture 7" descr="The same histogram with relative frequency on the vertical axis; the shape is identical, only the scale changes.">
-            <a:extLst>
-              <a:ext uri="{FF2B5EF4-FFF2-40B4-BE49-F238E27FC236}">
-                <a16:creationId xmlns:a16="http://schemas.microsoft.com/office/drawing/2014/main" id="{978CA529-7CC3-CAE2-9847-392C83BDC9D6}"/>
-              </a:ext>
-            </a:extLst>
-          </p:cNvPr>
-          <p:cNvPicPr>
-            <a:picLocks noChangeAspect="1"/>
-          </p:cNvPicPr>
-          <p:nvPr/>
-        </p:nvPicPr>
-        <p:blipFill>
-          <a:blip r:embed="rId4"/>
-          <a:stretch>
-            <a:fillRect/>
-          </a:stretch>
-        </p:blipFill>
-        <p:spPr>
-          <a:xfrm>
-            <a:off x="5920644" y="171451"/>
-            <a:ext cx="6271356" cy="3790950"/>
-          </a:xfrm>
-          <a:prstGeom prst="rect">
-            <a:avLst/>
-          </a:prstGeom>
-        </p:spPr>
-      </p:pic>
       <p:sp>
         <p:nvSpPr>
-          <p:cNvPr id="11" name="Title 1">
+          <p:cNvPr id="2" name="Title 1">
             <a:extLst>
               <a:ext uri="{FF2B5EF4-FFF2-40B4-BE49-F238E27FC236}">
-                <a16:creationId xmlns:a16="http://schemas.microsoft.com/office/drawing/2014/main" id="{4A4E0D4A-62CF-AB62-D6A7-48E60442E41C}"/>
+                <a16:creationId xmlns:a16="http://schemas.microsoft.com/office/drawing/2014/main" id="{8CBF7785-FEE9-FCDE-BE15-9C090217399B}"/>
               </a:ext>
             </a:extLst>
           </p:cNvPr>
@@ -9457,12 +9366,35 @@
             <p:ph type="title"/>
           </p:nvPr>
         </p:nvSpPr>
-        <p:spPr>
-          <a:xfrm>
-            <a:off x="560209" y="1546224"/>
-            <a:ext cx="4991100" cy="825500"/>
-          </a:xfrm>
-        </p:spPr>
+        <p:spPr/>
+        <p:txBody>
+          <a:bodyPr/>
+          <a:lstStyle/>
+          <a:p>
+            <a:r>
+              <a:rPr lang="en-US"/>
+              <a:t>Histogram: strengths and weaknesses</a:t>
+            </a:r>
+          </a:p>
+        </p:txBody>
+      </p:sp>
+      <p:sp>
+        <p:nvSpPr>
+          <p:cNvPr id="3" name="Content Placeholder 2">
+            <a:extLst>
+              <a:ext uri="{FF2B5EF4-FFF2-40B4-BE49-F238E27FC236}">
+                <a16:creationId xmlns:a16="http://schemas.microsoft.com/office/drawing/2014/main" id="{BF09BD64-F37A-6B24-63CE-8584D3FBB326}"/>
+              </a:ext>
+            </a:extLst>
+          </p:cNvPr>
+          <p:cNvSpPr>
+            <a:spLocks noGrp="1"/>
+          </p:cNvSpPr>
+          <p:nvPr>
+            <p:ph idx="1"/>
+          </p:nvPr>
+        </p:nvSpPr>
+        <p:spPr/>
         <p:txBody>
           <a:bodyPr>
             <a:normAutofit/>
@@ -9470,8 +9402,64 @@
           <a:lstStyle/>
           <a:p>
             <a:r>
-              <a:rPr lang="en-US" sz="2400" dirty="0"/>
-              <a:t>Example: Old Faithful Eruption Times</a:t>
+              <a:rPr lang="en-US" b="1">
+                <a:solidFill>
+                  <a:srgbClr val="1F7A4D"/>
+                </a:solidFill>
+              </a:rPr>
+              <a:t>Strengths</a:t>
+            </a:r>
+          </a:p>
+          <a:p>
+            <a:pPr lvl="1"/>
+            <a:r>
+              <a:rPr lang="en-US"/>
+              <a:t>A great way to get an idea of shape when the sample is medium or large (n &gt; 20)</a:t>
+            </a:r>
+          </a:p>
+          <a:p>
+            <a:pPr lvl="1"/>
+            <a:r>
+              <a:rPr lang="en-US"/>
+              <a:t>Handles continuous data at any sample size, and stays readable as n grows</a:t>
+            </a:r>
+          </a:p>
+          <a:p>
+            <a:pPr lvl="1"/>
+            <a:r>
+              <a:rPr lang="en-US"/>
+              <a:t>The standard choice for showing a distribution to someone else</a:t>
+            </a:r>
+          </a:p>
+          <a:p>
+            <a:r>
+              <a:rPr lang="en-US" b="1">
+                <a:solidFill>
+                  <a:srgbClr val="C00000"/>
+                </a:solidFill>
+              </a:rPr>
+              <a:t>Weaknesses</a:t>
+            </a:r>
+          </a:p>
+          <a:p>
+            <a:pPr lvl="1"/>
+            <a:r>
+              <a:rPr lang="en-US"/>
+              <a:t>Hides the individual observations: you see bars, not data points</a:t>
+            </a:r>
+          </a:p>
+          <a:p>
+            <a:pPr lvl="1"/>
+            <a:r>
+              <a:rPr lang="en-US"/>
+              <a:t>The shape depends on the number of bins, so it can distort shape for small samples</a:t>
+            </a:r>
+          </a:p>
+          <a:p>
+            <a:pPr lvl="1"/>
+            <a:r>
+              <a:rPr lang="en-US"/>
+              <a:t>Bin edges are arbitrary, and moving them can change the story the picture tells</a:t>
             </a:r>
           </a:p>
         </p:txBody>
@@ -9479,7 +9467,7 @@
     </p:spTree>
     <p:extLst>
       <p:ext uri="{BB962C8B-B14F-4D97-AF65-F5344CB8AC3E}">
-        <p14:creationId xmlns:p14="http://schemas.microsoft.com/office/powerpoint/2010/main" val="726230392"/>
+        <p14:creationId xmlns:p14="http://schemas.microsoft.com/office/powerpoint/2010/main" val="2725062704"/>
       </p:ext>
     </p:extLst>
   </p:cSld>
@@ -9511,7 +9499,7 @@
           <p:cNvPr id="2" name="Title 1">
             <a:extLst>
               <a:ext uri="{FF2B5EF4-FFF2-40B4-BE49-F238E27FC236}">
-                <a16:creationId xmlns:a16="http://schemas.microsoft.com/office/drawing/2014/main" id="{8CBF7785-FEE9-FCDE-BE15-9C090217399B}"/>
+                <a16:creationId xmlns:a16="http://schemas.microsoft.com/office/drawing/2014/main" id="{F75DF18B-03F1-B339-420D-B9726A8F58BE}"/>
               </a:ext>
             </a:extLst>
           </p:cNvPr>
@@ -9529,7 +9517,7 @@
           <a:p>
             <a:r>
               <a:rPr lang="en-US"/>
-              <a:t>Histogram: strengths and weaknesses</a:t>
+              <a:t>From pictures to numbers</a:t>
             </a:r>
           </a:p>
         </p:txBody>
@@ -9539,7 +9527,7 @@
           <p:cNvPr id="3" name="Content Placeholder 2">
             <a:extLst>
               <a:ext uri="{FF2B5EF4-FFF2-40B4-BE49-F238E27FC236}">
-                <a16:creationId xmlns:a16="http://schemas.microsoft.com/office/drawing/2014/main" id="{BF09BD64-F37A-6B24-63CE-8584D3FBB326}"/>
+                <a16:creationId xmlns:a16="http://schemas.microsoft.com/office/drawing/2014/main" id="{5363AFEC-517A-96A4-2E3F-C4B69D443121}"/>
               </a:ext>
             </a:extLst>
           </p:cNvPr>
@@ -9558,205 +9546,61 @@
           <a:lstStyle/>
           <a:p>
             <a:r>
-              <a:rPr lang="en-US" b="1">
-                <a:solidFill>
-                  <a:srgbClr val="1F7A4D"/>
-                </a:solidFill>
-              </a:rPr>
-              <a:t>Strengths</a:t>
-            </a:r>
-          </a:p>
-          <a:p>
-            <a:pPr lvl="1"/>
-            <a:r>
-              <a:rPr lang="en-US"/>
-              <a:t>A great way to get an idea of shape when the sample is medium or large (n &gt; 20)</a:t>
-            </a:r>
-          </a:p>
-          <a:p>
-            <a:pPr lvl="1"/>
-            <a:r>
-              <a:rPr lang="en-US"/>
-              <a:t>Handles continuous data at any sample size, and stays readable as n grows</a:t>
-            </a:r>
-          </a:p>
-          <a:p>
-            <a:pPr lvl="1"/>
-            <a:r>
-              <a:rPr lang="en-US"/>
-              <a:t>The standard choice for showing a distribution to someone else</a:t>
-            </a:r>
-          </a:p>
-          <a:p>
-            <a:r>
-              <a:rPr lang="en-US" b="1">
-                <a:solidFill>
-                  <a:srgbClr val="C00000"/>
-                </a:solidFill>
-              </a:rPr>
-              <a:t>Weaknesses</a:t>
-            </a:r>
-          </a:p>
-          <a:p>
-            <a:pPr lvl="1"/>
-            <a:r>
-              <a:rPr lang="en-US"/>
-              <a:t>Hides the individual observations: you see bars, not data points</a:t>
-            </a:r>
-          </a:p>
-          <a:p>
-            <a:pPr lvl="1"/>
-            <a:r>
-              <a:rPr lang="en-US"/>
-              <a:t>The shape depends on the number of bins, so it can distort shape for small samples</a:t>
-            </a:r>
-          </a:p>
-          <a:p>
-            <a:pPr lvl="1"/>
-            <a:r>
-              <a:rPr lang="en-US"/>
-              <a:t>Bin edges are arbitrary, and moving them can change the story the picture tells</a:t>
-            </a:r>
-          </a:p>
-        </p:txBody>
-      </p:sp>
-    </p:spTree>
-    <p:extLst>
-      <p:ext uri="{BB962C8B-B14F-4D97-AF65-F5344CB8AC3E}">
-        <p14:creationId xmlns:p14="http://schemas.microsoft.com/office/powerpoint/2010/main" val="2725062704"/>
-      </p:ext>
-    </p:extLst>
-  </p:cSld>
-  <p:clrMapOvr>
-    <a:masterClrMapping/>
-  </p:clrMapOvr>
-</p:sld>
-</file>
-
-<file path=ppt/slides/slide25.xml><?xml version="1.0" encoding="utf-8"?>
-<p:sld xmlns:a="http://schemas.openxmlformats.org/drawingml/2006/main" xmlns:r="http://schemas.openxmlformats.org/officeDocument/2006/relationships" xmlns:p="http://schemas.openxmlformats.org/presentationml/2006/main">
-  <p:cSld>
-    <p:spTree>
-      <p:nvGrpSpPr>
-        <p:cNvPr id="1" name=""/>
-        <p:cNvGrpSpPr/>
-        <p:nvPr/>
-      </p:nvGrpSpPr>
-      <p:grpSpPr>
-        <a:xfrm>
-          <a:off x="0" y="0"/>
-          <a:ext cx="0" cy="0"/>
-          <a:chOff x="0" y="0"/>
-          <a:chExt cx="0" cy="0"/>
-        </a:xfrm>
-      </p:grpSpPr>
-      <p:sp>
-        <p:nvSpPr>
-          <p:cNvPr id="2" name="Title 1">
-            <a:extLst>
-              <a:ext uri="{FF2B5EF4-FFF2-40B4-BE49-F238E27FC236}">
-                <a16:creationId xmlns:a16="http://schemas.microsoft.com/office/drawing/2014/main" id="{F75DF18B-03F1-B339-420D-B9726A8F58BE}"/>
-              </a:ext>
-            </a:extLst>
-          </p:cNvPr>
-          <p:cNvSpPr>
-            <a:spLocks noGrp="1"/>
-          </p:cNvSpPr>
-          <p:nvPr>
-            <p:ph type="title"/>
-          </p:nvPr>
-        </p:nvSpPr>
-        <p:spPr/>
-        <p:txBody>
-          <a:bodyPr/>
-          <a:lstStyle/>
-          <a:p>
-            <a:r>
-              <a:rPr lang="en-US"/>
-              <a:t>From pictures to numbers</a:t>
-            </a:r>
-          </a:p>
-        </p:txBody>
-      </p:sp>
-      <p:sp>
-        <p:nvSpPr>
-          <p:cNvPr id="3" name="Content Placeholder 2">
-            <a:extLst>
-              <a:ext uri="{FF2B5EF4-FFF2-40B4-BE49-F238E27FC236}">
-                <a16:creationId xmlns:a16="http://schemas.microsoft.com/office/drawing/2014/main" id="{5363AFEC-517A-96A4-2E3F-C4B69D443121}"/>
-              </a:ext>
-            </a:extLst>
-          </p:cNvPr>
-          <p:cNvSpPr>
-            <a:spLocks noGrp="1"/>
-          </p:cNvSpPr>
-          <p:nvPr>
-            <p:ph idx="1"/>
-          </p:nvPr>
-        </p:nvSpPr>
-        <p:spPr/>
-        <p:txBody>
-          <a:bodyPr>
-            <a:normAutofit/>
-          </a:bodyPr>
-          <a:lstStyle/>
-          <a:p>
-            <a:r>
-              <a:rPr lang="en-US" sz="1600" b="1"/>
+              <a:rPr lang="en-US" sz="2000" b="1" dirty="0"/>
               <a:t>Next: measures of location and position.</a:t>
             </a:r>
             <a:r>
-              <a:rPr lang="en-US" sz="1600"/>
+              <a:rPr lang="en-US" sz="2000" dirty="0"/>
               <a:t> Single numbers that say where a distribution sits.</a:t>
             </a:r>
           </a:p>
           <a:p>
             <a:r>
-              <a:rPr lang="en-US" sz="1600" b="1"/>
+              <a:rPr lang="en-US" sz="2000" b="1" dirty="0"/>
               <a:t>Numbers can be computed with.</a:t>
             </a:r>
             <a:r>
-              <a:rPr lang="en-US" sz="1600"/>
+              <a:rPr lang="en-US" sz="2000" dirty="0"/>
               <a:t> A graph is read by eye. A statistic goes into a table, a comparison, or a hypothesis test.</a:t>
             </a:r>
           </a:p>
           <a:p>
             <a:r>
-              <a:rPr lang="en-US" sz="1600" b="1"/>
+              <a:rPr lang="en-US" sz="2000" b="1" dirty="0"/>
               <a:t>"What is a typical value?"</a:t>
             </a:r>
             <a:r>
-              <a:rPr lang="en-US" sz="1600"/>
+              <a:rPr lang="en-US" sz="2000" dirty="0"/>
               <a:t> The first question anyone asks of a dataset, and the mean, median and mode each answer it differently.</a:t>
             </a:r>
           </a:p>
           <a:p>
             <a:r>
-              <a:rPr lang="en-US" sz="1600" b="1"/>
+              <a:rPr lang="en-US" sz="2000" b="1" dirty="0"/>
               <a:t>Comparing groups.</a:t>
             </a:r>
             <a:r>
-              <a:rPr lang="en-US" sz="1600"/>
+              <a:rPr lang="en-US" sz="2000" dirty="0"/>
               <a:t> Two samples are compared through their centers, not by squinting at two histograms.</a:t>
             </a:r>
           </a:p>
           <a:p>
             <a:r>
-              <a:rPr lang="en-US" sz="1600" b="1"/>
+              <a:rPr lang="en-US" sz="2000" b="1" dirty="0"/>
               <a:t>Where does one observation sit?</a:t>
             </a:r>
             <a:r>
-              <a:rPr lang="en-US" sz="1600"/>
+              <a:rPr lang="en-US" sz="2000" dirty="0"/>
               <a:t> A score of 78 means little until you know it falls at the 90th percentile.</a:t>
             </a:r>
           </a:p>
           <a:p>
             <a:r>
-              <a:rPr lang="en-US" sz="1600" b="1"/>
+              <a:rPr lang="en-US" sz="2000" b="1" dirty="0"/>
               <a:t>Shape decides which measure to trust.</a:t>
             </a:r>
             <a:r>
-              <a:rPr lang="en-US" sz="1600"/>
+              <a:rPr lang="en-US" sz="2000" dirty="0"/>
               <a:t> Skew and outliers drag the mean but leave the median alone, which is why we did shape first.</a:t>
             </a:r>
           </a:p>
@@ -9775,7 +9619,7 @@
 </p:sld>
 </file>
 
-<file path=ppt/slides/slide26.xml><?xml version="1.0" encoding="utf-8"?>
+<file path=ppt/slides/slide25.xml><?xml version="1.0" encoding="utf-8"?>
 <p:sld xmlns:a="http://schemas.openxmlformats.org/drawingml/2006/main" xmlns:r="http://schemas.openxmlformats.org/officeDocument/2006/relationships" xmlns:p="http://schemas.openxmlformats.org/presentationml/2006/main">
   <p:cSld>
     <p:spTree>
@@ -10218,7 +10062,7 @@
 </p:sld>
 </file>
 
-<file path=ppt/slides/slide27.xml><?xml version="1.0" encoding="utf-8"?>
+<file path=ppt/slides/slide26.xml><?xml version="1.0" encoding="utf-8"?>
 <p:sld xmlns:a="http://schemas.openxmlformats.org/drawingml/2006/main" xmlns:r="http://schemas.openxmlformats.org/officeDocument/2006/relationships" xmlns:p="http://schemas.openxmlformats.org/presentationml/2006/main">
   <p:cSld>
     <p:spTree>
@@ -10369,7 +10213,7 @@
 </p:sld>
 </file>
 
-<file path=ppt/slides/slide28.xml><?xml version="1.0" encoding="utf-8"?>
+<file path=ppt/slides/slide27.xml><?xml version="1.0" encoding="utf-8"?>
 <p:sld xmlns:a="http://schemas.openxmlformats.org/drawingml/2006/main" xmlns:r="http://schemas.openxmlformats.org/officeDocument/2006/relationships" xmlns:p="http://schemas.openxmlformats.org/presentationml/2006/main">
   <p:cSld>
     <p:spTree>
@@ -10596,7 +10440,7 @@
 </p:sld>
 </file>
 
-<file path=ppt/slides/slide29.xml><?xml version="1.0" encoding="utf-8"?>
+<file path=ppt/slides/slide28.xml><?xml version="1.0" encoding="utf-8"?>
 <p:sld xmlns:a="http://schemas.openxmlformats.org/drawingml/2006/main" xmlns:r="http://schemas.openxmlformats.org/officeDocument/2006/relationships" xmlns:p="http://schemas.openxmlformats.org/presentationml/2006/main">
   <p:cSld>
     <p:spTree>
@@ -10744,820 +10588,7 @@
 </p:sld>
 </file>
 
-<file path=ppt/slides/slide3.xml><?xml version="1.0" encoding="utf-8"?>
-<p:sld xmlns:a="http://schemas.openxmlformats.org/drawingml/2006/main" xmlns:r="http://schemas.openxmlformats.org/officeDocument/2006/relationships" xmlns:p="http://schemas.openxmlformats.org/presentationml/2006/main">
-  <p:cSld>
-    <p:spTree>
-      <p:nvGrpSpPr>
-        <p:cNvPr id="1" name=""/>
-        <p:cNvGrpSpPr/>
-        <p:nvPr/>
-      </p:nvGrpSpPr>
-      <p:grpSpPr>
-        <a:xfrm>
-          <a:off x="0" y="0"/>
-          <a:ext cx="0" cy="0"/>
-          <a:chOff x="0" y="0"/>
-          <a:chExt cx="0" cy="0"/>
-        </a:xfrm>
-      </p:grpSpPr>
-      <p:sp>
-        <p:nvSpPr>
-          <p:cNvPr id="2" name="Title 1"/>
-          <p:cNvSpPr>
-            <a:spLocks noGrp="1"/>
-          </p:cNvSpPr>
-          <p:nvPr>
-            <p:ph type="title"/>
-          </p:nvPr>
-        </p:nvSpPr>
-        <p:spPr>
-          <a:xfrm>
-            <a:off x="838200" y="365126"/>
-            <a:ext cx="10515600" cy="519130"/>
-          </a:xfrm>
-        </p:spPr>
-        <p:txBody>
-          <a:bodyPr>
-            <a:normAutofit fontScale="90000"/>
-          </a:bodyPr>
-          <a:lstStyle/>
-          <a:p>
-            <a:r>
-              <a:rPr lang="en-US" dirty="0"/>
-              <a:t>Review</a:t>
-            </a:r>
-          </a:p>
-        </p:txBody>
-      </p:sp>
-      <p:sp>
-        <p:nvSpPr>
-          <p:cNvPr id="3" name="Question 1"/>
-          <p:cNvSpPr/>
-          <p:nvPr/>
-        </p:nvSpPr>
-        <p:spPr>
-          <a:xfrm>
-            <a:off x="838200" y="1075688"/>
-            <a:ext cx="10515600" cy="1230000"/>
-          </a:xfrm>
-          <a:prstGeom prst="roundRect">
-            <a:avLst>
-              <a:gd name="adj" fmla="val 4000"/>
-            </a:avLst>
-          </a:prstGeom>
-          <a:solidFill>
-            <a:srgbClr val="F2F6FC"/>
-          </a:solidFill>
-          <a:ln w="19050">
-            <a:solidFill>
-              <a:schemeClr val="accent1"/>
-            </a:solidFill>
-          </a:ln>
-        </p:spPr>
-        <p:txBody>
-          <a:bodyPr lIns="228600" tIns="182880" rIns="228600" bIns="91440" anchor="t">
-            <a:normAutofit/>
-          </a:bodyPr>
-          <a:lstStyle/>
-          <a:p>
-            <a:pPr marL="0" indent="0">
-              <a:buNone/>
-            </a:pPr>
-            <a:r>
-              <a:rPr lang="en-US" b="1">
-                <a:solidFill>
-                  <a:srgbClr val="4472C4"/>
-                </a:solidFill>
-              </a:rPr>
-              <a:t>1   </a:t>
-            </a:r>
-            <a:r>
-              <a:rPr lang="en-US" b="1"/>
-              <a:t>How do we bin a continuous variable?</a:t>
-            </a:r>
-            <a:endParaRPr lang="en-US" b="1" dirty="0"/>
-          </a:p>
-        </p:txBody>
-      </p:sp>
-      <p:sp>
-        <p:nvSpPr>
-          <p:cNvPr id="4" name="Answer 1"/>
-          <p:cNvSpPr txBox="1"/>
-          <p:nvPr/>
-        </p:nvSpPr>
-        <p:spPr>
-          <a:xfrm>
-            <a:off x="1066800" y="1655688"/>
-            <a:ext cx="10058400" cy="558560"/>
-          </a:xfrm>
-          <a:prstGeom prst="rect">
-            <a:avLst/>
-          </a:prstGeom>
-          <a:noFill/>
-        </p:spPr>
-        <p:txBody>
-          <a:bodyPr wrap="square" lIns="0" tIns="0" rIns="0" bIns="0">
-            <a:normAutofit/>
-          </a:bodyPr>
-          <a:lstStyle/>
-          <a:p>
-            <a:pPr marL="0" indent="0">
-              <a:buNone/>
-            </a:pPr>
-            <a:r>
-              <a:rPr lang="en-US">
-                <a:solidFill>
-                  <a:srgbClr val="C00000"/>
-                </a:solidFill>
-              </a:rPr>
-              <a:t>Divide the range into K non-overlapping intervals of equal width, then count how many fall in each.</a:t>
-            </a:r>
-            <a:endParaRPr lang="en-US" dirty="0">
-              <a:solidFill>
-                <a:srgbClr val="C00000"/>
-              </a:solidFill>
-            </a:endParaRPr>
-          </a:p>
-        </p:txBody>
-      </p:sp>
-      <p:sp>
-        <p:nvSpPr>
-          <p:cNvPr id="5" name="Question 2"/>
-          <p:cNvSpPr/>
-          <p:nvPr/>
-        </p:nvSpPr>
-        <p:spPr>
-          <a:xfrm>
-            <a:off x="838200" y="2385688"/>
-            <a:ext cx="10515600" cy="1230000"/>
-          </a:xfrm>
-          <a:prstGeom prst="roundRect">
-            <a:avLst>
-              <a:gd name="adj" fmla="val 4000"/>
-            </a:avLst>
-          </a:prstGeom>
-          <a:solidFill>
-            <a:srgbClr val="F2F6FC"/>
-          </a:solidFill>
-          <a:ln w="19050">
-            <a:solidFill>
-              <a:schemeClr val="accent1"/>
-            </a:solidFill>
-          </a:ln>
-        </p:spPr>
-        <p:txBody>
-          <a:bodyPr lIns="228600" tIns="182880" rIns="228600" bIns="91440" anchor="t">
-            <a:normAutofit/>
-          </a:bodyPr>
-          <a:lstStyle/>
-          <a:p>
-            <a:pPr marL="0" indent="0">
-              <a:buNone/>
-            </a:pPr>
-            <a:r>
-              <a:rPr lang="en-US" b="1">
-                <a:solidFill>
-                  <a:srgbClr val="4472C4"/>
-                </a:solidFill>
-              </a:rPr>
-              <a:t>2   </a:t>
-            </a:r>
-            <a:r>
-              <a:rPr lang="en-US" b="1"/>
-              <a:t>Which graphs do we use for a qualitative variable?</a:t>
-            </a:r>
-            <a:endParaRPr lang="en-US" b="1" dirty="0"/>
-          </a:p>
-        </p:txBody>
-      </p:sp>
-      <p:sp>
-        <p:nvSpPr>
-          <p:cNvPr id="6" name="Answer 2"/>
-          <p:cNvSpPr txBox="1"/>
-          <p:nvPr/>
-        </p:nvSpPr>
-        <p:spPr>
-          <a:xfrm>
-            <a:off x="1066800" y="2965688"/>
-            <a:ext cx="10058400" cy="558560"/>
-          </a:xfrm>
-          <a:prstGeom prst="rect">
-            <a:avLst/>
-          </a:prstGeom>
-          <a:noFill/>
-        </p:spPr>
-        <p:txBody>
-          <a:bodyPr wrap="square" lIns="0" tIns="0" rIns="0" bIns="0">
-            <a:normAutofit/>
-          </a:bodyPr>
-          <a:lstStyle/>
-          <a:p>
-            <a:pPr marL="0" indent="0">
-              <a:buNone/>
-            </a:pPr>
-            <a:r>
-              <a:rPr lang="en-US" sz="1600">
-                <a:solidFill>
-                  <a:srgbClr val="C00000"/>
-                </a:solidFill>
-              </a:rPr>
-              <a:t>Bar graphs, pie charts, and Pareto charts.</a:t>
-            </a:r>
-            <a:endParaRPr lang="en-US" sz="1600" dirty="0">
-              <a:solidFill>
-                <a:srgbClr val="C00000"/>
-              </a:solidFill>
-            </a:endParaRPr>
-          </a:p>
-        </p:txBody>
-      </p:sp>
-      <p:sp>
-        <p:nvSpPr>
-          <p:cNvPr id="7" name="Question 3"/>
-          <p:cNvSpPr/>
-          <p:nvPr/>
-        </p:nvSpPr>
-        <p:spPr>
-          <a:xfrm>
-            <a:off x="838200" y="3695688"/>
-            <a:ext cx="10515600" cy="1230000"/>
-          </a:xfrm>
-          <a:prstGeom prst="roundRect">
-            <a:avLst>
-              <a:gd name="adj" fmla="val 4000"/>
-            </a:avLst>
-          </a:prstGeom>
-          <a:solidFill>
-            <a:srgbClr val="F2F6FC"/>
-          </a:solidFill>
-          <a:ln w="19050">
-            <a:solidFill>
-              <a:schemeClr val="accent1"/>
-            </a:solidFill>
-          </a:ln>
-        </p:spPr>
-        <p:txBody>
-          <a:bodyPr lIns="228600" tIns="182880" rIns="228600" bIns="91440" anchor="t">
-            <a:normAutofit/>
-          </a:bodyPr>
-          <a:lstStyle/>
-          <a:p>
-            <a:pPr marL="0" indent="0">
-              <a:buNone/>
-            </a:pPr>
-            <a:r>
-              <a:rPr lang="en-US" b="1">
-                <a:solidFill>
-                  <a:srgbClr val="4472C4"/>
-                </a:solidFill>
-              </a:rPr>
-              <a:t>3   </a:t>
-            </a:r>
-            <a:r>
-              <a:rPr lang="en-US" b="1"/>
-              <a:t>Which graphs do we use for a quantitative variable?</a:t>
-            </a:r>
-            <a:endParaRPr lang="en-US" b="1" dirty="0"/>
-          </a:p>
-        </p:txBody>
-      </p:sp>
-      <p:sp>
-        <p:nvSpPr>
-          <p:cNvPr id="8" name="Answer 3"/>
-          <p:cNvSpPr txBox="1"/>
-          <p:nvPr/>
-        </p:nvSpPr>
-        <p:spPr>
-          <a:xfrm>
-            <a:off x="1066800" y="4275688"/>
-            <a:ext cx="10058400" cy="558560"/>
-          </a:xfrm>
-          <a:prstGeom prst="rect">
-            <a:avLst/>
-          </a:prstGeom>
-          <a:noFill/>
-        </p:spPr>
-        <p:txBody>
-          <a:bodyPr wrap="square" lIns="0" tIns="0" rIns="0" bIns="0">
-            <a:normAutofit/>
-          </a:bodyPr>
-          <a:lstStyle/>
-          <a:p>
-            <a:pPr marL="0" indent="0">
-              <a:buNone/>
-            </a:pPr>
-            <a:r>
-              <a:rPr lang="en-US" sz="1600">
-                <a:solidFill>
-                  <a:srgbClr val="C00000"/>
-                </a:solidFill>
-              </a:rPr>
-              <a:t>Dot plots, stem and leaf plots, and histograms – today's topic.</a:t>
-            </a:r>
-            <a:endParaRPr lang="en-US" sz="1600" dirty="0">
-              <a:solidFill>
-                <a:srgbClr val="C00000"/>
-              </a:solidFill>
-            </a:endParaRPr>
-          </a:p>
-        </p:txBody>
-      </p:sp>
-      <p:sp>
-        <p:nvSpPr>
-          <p:cNvPr id="9" name="Question 4"/>
-          <p:cNvSpPr/>
-          <p:nvPr/>
-        </p:nvSpPr>
-        <p:spPr>
-          <a:xfrm>
-            <a:off x="838200" y="5005688"/>
-            <a:ext cx="10515600" cy="1230000"/>
-          </a:xfrm>
-          <a:prstGeom prst="roundRect">
-            <a:avLst>
-              <a:gd name="adj" fmla="val 4000"/>
-            </a:avLst>
-          </a:prstGeom>
-          <a:solidFill>
-            <a:srgbClr val="F2F6FC"/>
-          </a:solidFill>
-          <a:ln w="19050">
-            <a:solidFill>
-              <a:schemeClr val="accent1"/>
-            </a:solidFill>
-          </a:ln>
-        </p:spPr>
-        <p:txBody>
-          <a:bodyPr lIns="228600" tIns="182880" rIns="228600" bIns="91440" anchor="t">
-            <a:normAutofit/>
-          </a:bodyPr>
-          <a:lstStyle/>
-          <a:p>
-            <a:pPr marL="0" indent="0">
-              <a:buNone/>
-            </a:pPr>
-            <a:r>
-              <a:rPr lang="en-US" b="1">
-                <a:solidFill>
-                  <a:srgbClr val="4472C4"/>
-                </a:solidFill>
-              </a:rPr>
-              <a:t>4   </a:t>
-            </a:r>
-            <a:r>
-              <a:rPr lang="en-US" b="1"/>
-              <a:t>Why graph the data when we already have the frequency table?</a:t>
-            </a:r>
-            <a:endParaRPr lang="en-US" b="1" dirty="0"/>
-          </a:p>
-        </p:txBody>
-      </p:sp>
-      <p:sp>
-        <p:nvSpPr>
-          <p:cNvPr id="10" name="Answer 4"/>
-          <p:cNvSpPr txBox="1"/>
-          <p:nvPr/>
-        </p:nvSpPr>
-        <p:spPr>
-          <a:xfrm>
-            <a:off x="1066800" y="5585688"/>
-            <a:ext cx="10058400" cy="558560"/>
-          </a:xfrm>
-          <a:prstGeom prst="rect">
-            <a:avLst/>
-          </a:prstGeom>
-          <a:noFill/>
-        </p:spPr>
-        <p:txBody>
-          <a:bodyPr wrap="square" lIns="0" tIns="0" rIns="0" bIns="0">
-            <a:normAutofit/>
-          </a:bodyPr>
-          <a:lstStyle/>
-          <a:p>
-            <a:pPr marL="0" indent="0">
-              <a:buNone/>
-            </a:pPr>
-            <a:r>
-              <a:rPr lang="en-US" sz="1600">
-                <a:solidFill>
-                  <a:srgbClr val="C00000"/>
-                </a:solidFill>
-              </a:rPr>
-              <a:t>The graph shows shape, center, and spread at a glance, along with any outliers.</a:t>
-            </a:r>
-            <a:endParaRPr lang="en-US" sz="1600" dirty="0">
-              <a:solidFill>
-                <a:srgbClr val="C00000"/>
-              </a:solidFill>
-            </a:endParaRPr>
-          </a:p>
-        </p:txBody>
-      </p:sp>
-    </p:spTree>
-    <p:extLst>
-      <p:ext uri="{BB962C8B-B14F-4D97-AF65-F5344CB8AC3E}">
-        <p14:creationId xmlns:p14="http://schemas.microsoft.com/office/powerpoint/2010/main" val="1517484012"/>
-      </p:ext>
-    </p:extLst>
-  </p:cSld>
-  <p:clrMapOvr>
-    <a:masterClrMapping/>
-  </p:clrMapOvr>
-  <p:timing>
-    <p:tnLst>
-      <p:par>
-        <p:cTn id="1" dur="indefinite" restart="never" nodeType="tmRoot">
-          <p:childTnLst>
-            <p:seq concurrent="1" nextAc="seek">
-              <p:cTn id="2" dur="indefinite" nodeType="mainSeq">
-                <p:childTnLst>
-                  <p:par>
-                    <p:cTn id="3" fill="hold">
-                      <p:stCondLst>
-                        <p:cond delay="indefinite"/>
-                      </p:stCondLst>
-                      <p:childTnLst>
-                        <p:par>
-                          <p:cTn id="4" fill="hold">
-                            <p:stCondLst>
-                              <p:cond delay="0"/>
-                            </p:stCondLst>
-                            <p:childTnLst>
-                              <p:par>
-                                <p:cTn id="5" presetID="1" presetClass="entr" presetSubtype="0" fill="hold" nodeType="clickEffect">
-                                  <p:stCondLst>
-                                    <p:cond delay="0"/>
-                                  </p:stCondLst>
-                                  <p:childTnLst>
-                                    <p:set>
-                                      <p:cBhvr>
-                                        <p:cTn id="6" dur="1" fill="hold">
-                                          <p:stCondLst>
-                                            <p:cond delay="0"/>
-                                          </p:stCondLst>
-                                        </p:cTn>
-                                        <p:tgtEl>
-                                          <p:spTgt spid="3"/>
-                                        </p:tgtEl>
-                                        <p:attrNameLst>
-                                          <p:attrName>style.visibility</p:attrName>
-                                        </p:attrNameLst>
-                                      </p:cBhvr>
-                                      <p:to>
-                                        <p:strVal val="visible"/>
-                                      </p:to>
-                                    </p:set>
-                                  </p:childTnLst>
-                                </p:cTn>
-                              </p:par>
-                            </p:childTnLst>
-                          </p:cTn>
-                        </p:par>
-                      </p:childTnLst>
-                    </p:cTn>
-                  </p:par>
-                  <p:par>
-                    <p:cTn id="7" fill="hold">
-                      <p:stCondLst>
-                        <p:cond delay="indefinite"/>
-                      </p:stCondLst>
-                      <p:childTnLst>
-                        <p:par>
-                          <p:cTn id="8" fill="hold">
-                            <p:stCondLst>
-                              <p:cond delay="0"/>
-                            </p:stCondLst>
-                            <p:childTnLst>
-                              <p:par>
-                                <p:cTn id="9" presetID="1" presetClass="entr" presetSubtype="0" fill="hold" nodeType="clickEffect">
-                                  <p:stCondLst>
-                                    <p:cond delay="0"/>
-                                  </p:stCondLst>
-                                  <p:childTnLst>
-                                    <p:set>
-                                      <p:cBhvr>
-                                        <p:cTn id="10" dur="1" fill="hold">
-                                          <p:stCondLst>
-                                            <p:cond delay="0"/>
-                                          </p:stCondLst>
-                                        </p:cTn>
-                                        <p:tgtEl>
-                                          <p:spTgt spid="4"/>
-                                        </p:tgtEl>
-                                        <p:attrNameLst>
-                                          <p:attrName>style.visibility</p:attrName>
-                                        </p:attrNameLst>
-                                      </p:cBhvr>
-                                      <p:to>
-                                        <p:strVal val="visible"/>
-                                      </p:to>
-                                    </p:set>
-                                  </p:childTnLst>
-                                </p:cTn>
-                              </p:par>
-                            </p:childTnLst>
-                          </p:cTn>
-                        </p:par>
-                      </p:childTnLst>
-                    </p:cTn>
-                  </p:par>
-                  <p:par>
-                    <p:cTn id="11" fill="hold">
-                      <p:stCondLst>
-                        <p:cond delay="indefinite"/>
-                      </p:stCondLst>
-                      <p:childTnLst>
-                        <p:par>
-                          <p:cTn id="12" fill="hold">
-                            <p:stCondLst>
-                              <p:cond delay="0"/>
-                            </p:stCondLst>
-                            <p:childTnLst>
-                              <p:par>
-                                <p:cTn id="13" presetID="1" presetClass="entr" presetSubtype="0" fill="hold" nodeType="clickEffect">
-                                  <p:stCondLst>
-                                    <p:cond delay="0"/>
-                                  </p:stCondLst>
-                                  <p:childTnLst>
-                                    <p:set>
-                                      <p:cBhvr>
-                                        <p:cTn id="14" dur="1" fill="hold">
-                                          <p:stCondLst>
-                                            <p:cond delay="0"/>
-                                          </p:stCondLst>
-                                        </p:cTn>
-                                        <p:tgtEl>
-                                          <p:spTgt spid="5"/>
-                                        </p:tgtEl>
-                                        <p:attrNameLst>
-                                          <p:attrName>style.visibility</p:attrName>
-                                        </p:attrNameLst>
-                                      </p:cBhvr>
-                                      <p:to>
-                                        <p:strVal val="visible"/>
-                                      </p:to>
-                                    </p:set>
-                                  </p:childTnLst>
-                                </p:cTn>
-                              </p:par>
-                            </p:childTnLst>
-                          </p:cTn>
-                        </p:par>
-                      </p:childTnLst>
-                    </p:cTn>
-                  </p:par>
-                  <p:par>
-                    <p:cTn id="15" fill="hold">
-                      <p:stCondLst>
-                        <p:cond delay="indefinite"/>
-                      </p:stCondLst>
-                      <p:childTnLst>
-                        <p:par>
-                          <p:cTn id="16" fill="hold">
-                            <p:stCondLst>
-                              <p:cond delay="0"/>
-                            </p:stCondLst>
-                            <p:childTnLst>
-                              <p:par>
-                                <p:cTn id="17" presetID="1" presetClass="entr" presetSubtype="0" fill="hold" nodeType="clickEffect">
-                                  <p:stCondLst>
-                                    <p:cond delay="0"/>
-                                  </p:stCondLst>
-                                  <p:childTnLst>
-                                    <p:set>
-                                      <p:cBhvr>
-                                        <p:cTn id="18" dur="1" fill="hold">
-                                          <p:stCondLst>
-                                            <p:cond delay="0"/>
-                                          </p:stCondLst>
-                                        </p:cTn>
-                                        <p:tgtEl>
-                                          <p:spTgt spid="6"/>
-                                        </p:tgtEl>
-                                        <p:attrNameLst>
-                                          <p:attrName>style.visibility</p:attrName>
-                                        </p:attrNameLst>
-                                      </p:cBhvr>
-                                      <p:to>
-                                        <p:strVal val="visible"/>
-                                      </p:to>
-                                    </p:set>
-                                  </p:childTnLst>
-                                </p:cTn>
-                              </p:par>
-                            </p:childTnLst>
-                          </p:cTn>
-                        </p:par>
-                      </p:childTnLst>
-                    </p:cTn>
-                  </p:par>
-                  <p:par>
-                    <p:cTn id="19" fill="hold">
-                      <p:stCondLst>
-                        <p:cond delay="indefinite"/>
-                      </p:stCondLst>
-                      <p:childTnLst>
-                        <p:par>
-                          <p:cTn id="20" fill="hold">
-                            <p:stCondLst>
-                              <p:cond delay="0"/>
-                            </p:stCondLst>
-                            <p:childTnLst>
-                              <p:par>
-                                <p:cTn id="21" presetID="1" presetClass="entr" presetSubtype="0" fill="hold" nodeType="clickEffect">
-                                  <p:stCondLst>
-                                    <p:cond delay="0"/>
-                                  </p:stCondLst>
-                                  <p:childTnLst>
-                                    <p:set>
-                                      <p:cBhvr>
-                                        <p:cTn id="22" dur="1" fill="hold">
-                                          <p:stCondLst>
-                                            <p:cond delay="0"/>
-                                          </p:stCondLst>
-                                        </p:cTn>
-                                        <p:tgtEl>
-                                          <p:spTgt spid="7"/>
-                                        </p:tgtEl>
-                                        <p:attrNameLst>
-                                          <p:attrName>style.visibility</p:attrName>
-                                        </p:attrNameLst>
-                                      </p:cBhvr>
-                                      <p:to>
-                                        <p:strVal val="visible"/>
-                                      </p:to>
-                                    </p:set>
-                                  </p:childTnLst>
-                                </p:cTn>
-                              </p:par>
-                            </p:childTnLst>
-                          </p:cTn>
-                        </p:par>
-                      </p:childTnLst>
-                    </p:cTn>
-                  </p:par>
-                  <p:par>
-                    <p:cTn id="23" fill="hold">
-                      <p:stCondLst>
-                        <p:cond delay="indefinite"/>
-                      </p:stCondLst>
-                      <p:childTnLst>
-                        <p:par>
-                          <p:cTn id="24" fill="hold">
-                            <p:stCondLst>
-                              <p:cond delay="0"/>
-                            </p:stCondLst>
-                            <p:childTnLst>
-                              <p:par>
-                                <p:cTn id="25" presetID="1" presetClass="entr" presetSubtype="0" fill="hold" nodeType="clickEffect">
-                                  <p:stCondLst>
-                                    <p:cond delay="0"/>
-                                  </p:stCondLst>
-                                  <p:childTnLst>
-                                    <p:set>
-                                      <p:cBhvr>
-                                        <p:cTn id="26" dur="1" fill="hold">
-                                          <p:stCondLst>
-                                            <p:cond delay="0"/>
-                                          </p:stCondLst>
-                                        </p:cTn>
-                                        <p:tgtEl>
-                                          <p:spTgt spid="8"/>
-                                        </p:tgtEl>
-                                        <p:attrNameLst>
-                                          <p:attrName>style.visibility</p:attrName>
-                                        </p:attrNameLst>
-                                      </p:cBhvr>
-                                      <p:to>
-                                        <p:strVal val="visible"/>
-                                      </p:to>
-                                    </p:set>
-                                  </p:childTnLst>
-                                </p:cTn>
-                              </p:par>
-                            </p:childTnLst>
-                          </p:cTn>
-                        </p:par>
-                      </p:childTnLst>
-                    </p:cTn>
-                  </p:par>
-                  <p:par>
-                    <p:cTn id="27" fill="hold">
-                      <p:stCondLst>
-                        <p:cond delay="indefinite"/>
-                      </p:stCondLst>
-                      <p:childTnLst>
-                        <p:par>
-                          <p:cTn id="28" fill="hold">
-                            <p:stCondLst>
-                              <p:cond delay="0"/>
-                            </p:stCondLst>
-                            <p:childTnLst>
-                              <p:par>
-                                <p:cTn id="29" presetID="1" presetClass="entr" presetSubtype="0" fill="hold" nodeType="clickEffect">
-                                  <p:stCondLst>
-                                    <p:cond delay="0"/>
-                                  </p:stCondLst>
-                                  <p:childTnLst>
-                                    <p:set>
-                                      <p:cBhvr>
-                                        <p:cTn id="30" dur="1" fill="hold">
-                                          <p:stCondLst>
-                                            <p:cond delay="0"/>
-                                          </p:stCondLst>
-                                        </p:cTn>
-                                        <p:tgtEl>
-                                          <p:spTgt spid="9"/>
-                                        </p:tgtEl>
-                                        <p:attrNameLst>
-                                          <p:attrName>style.visibility</p:attrName>
-                                        </p:attrNameLst>
-                                      </p:cBhvr>
-                                      <p:to>
-                                        <p:strVal val="visible"/>
-                                      </p:to>
-                                    </p:set>
-                                  </p:childTnLst>
-                                </p:cTn>
-                              </p:par>
-                            </p:childTnLst>
-                          </p:cTn>
-                        </p:par>
-                      </p:childTnLst>
-                    </p:cTn>
-                  </p:par>
-                  <p:par>
-                    <p:cTn id="31" fill="hold">
-                      <p:stCondLst>
-                        <p:cond delay="indefinite"/>
-                      </p:stCondLst>
-                      <p:childTnLst>
-                        <p:par>
-                          <p:cTn id="32" fill="hold">
-                            <p:stCondLst>
-                              <p:cond delay="0"/>
-                            </p:stCondLst>
-                            <p:childTnLst>
-                              <p:par>
-                                <p:cTn id="33" presetID="1" presetClass="entr" presetSubtype="0" fill="hold" nodeType="clickEffect">
-                                  <p:stCondLst>
-                                    <p:cond delay="0"/>
-                                  </p:stCondLst>
-                                  <p:childTnLst>
-                                    <p:set>
-                                      <p:cBhvr>
-                                        <p:cTn id="34" dur="1" fill="hold">
-                                          <p:stCondLst>
-                                            <p:cond delay="0"/>
-                                          </p:stCondLst>
-                                        </p:cTn>
-                                        <p:tgtEl>
-                                          <p:spTgt spid="10"/>
-                                        </p:tgtEl>
-                                        <p:attrNameLst>
-                                          <p:attrName>style.visibility</p:attrName>
-                                        </p:attrNameLst>
-                                      </p:cBhvr>
-                                      <p:to>
-                                        <p:strVal val="visible"/>
-                                      </p:to>
-                                    </p:set>
-                                  </p:childTnLst>
-                                </p:cTn>
-                              </p:par>
-                            </p:childTnLst>
-                          </p:cTn>
-                        </p:par>
-                      </p:childTnLst>
-                    </p:cTn>
-                  </p:par>
-                </p:childTnLst>
-              </p:cTn>
-              <p:prevCondLst>
-                <p:cond evt="onPrev" delay="0">
-                  <p:tgtEl>
-                    <p:sldTgt/>
-                  </p:tgtEl>
-                </p:cond>
-              </p:prevCondLst>
-              <p:nextCondLst>
-                <p:cond evt="onNext" delay="0">
-                  <p:tgtEl>
-                    <p:sldTgt/>
-                  </p:tgtEl>
-                </p:cond>
-              </p:nextCondLst>
-            </p:seq>
-          </p:childTnLst>
-        </p:cTn>
-      </p:par>
-    </p:tnLst>
-  </p:timing>
-</p:sld>
-</file>
-
-<file path=ppt/slides/slide30.xml><?xml version="1.0" encoding="utf-8"?>
+<file path=ppt/slides/slide29.xml><?xml version="1.0" encoding="utf-8"?>
 <p:sld xmlns:a="http://schemas.openxmlformats.org/drawingml/2006/main" xmlns:r="http://schemas.openxmlformats.org/officeDocument/2006/relationships" xmlns:p="http://schemas.openxmlformats.org/presentationml/2006/main">
   <p:cSld>
     <p:spTree>
@@ -12589,7 +11620,820 @@
 </p:sld>
 </file>
 
-<file path=ppt/slides/slide31.xml><?xml version="1.0" encoding="utf-8"?>
+<file path=ppt/slides/slide3.xml><?xml version="1.0" encoding="utf-8"?>
+<p:sld xmlns:a="http://schemas.openxmlformats.org/drawingml/2006/main" xmlns:r="http://schemas.openxmlformats.org/officeDocument/2006/relationships" xmlns:p="http://schemas.openxmlformats.org/presentationml/2006/main">
+  <p:cSld>
+    <p:spTree>
+      <p:nvGrpSpPr>
+        <p:cNvPr id="1" name=""/>
+        <p:cNvGrpSpPr/>
+        <p:nvPr/>
+      </p:nvGrpSpPr>
+      <p:grpSpPr>
+        <a:xfrm>
+          <a:off x="0" y="0"/>
+          <a:ext cx="0" cy="0"/>
+          <a:chOff x="0" y="0"/>
+          <a:chExt cx="0" cy="0"/>
+        </a:xfrm>
+      </p:grpSpPr>
+      <p:sp>
+        <p:nvSpPr>
+          <p:cNvPr id="2" name="Title 1"/>
+          <p:cNvSpPr>
+            <a:spLocks noGrp="1"/>
+          </p:cNvSpPr>
+          <p:nvPr>
+            <p:ph type="title"/>
+          </p:nvPr>
+        </p:nvSpPr>
+        <p:spPr>
+          <a:xfrm>
+            <a:off x="838200" y="365126"/>
+            <a:ext cx="10515600" cy="519130"/>
+          </a:xfrm>
+        </p:spPr>
+        <p:txBody>
+          <a:bodyPr>
+            <a:normAutofit fontScale="90000"/>
+          </a:bodyPr>
+          <a:lstStyle/>
+          <a:p>
+            <a:r>
+              <a:rPr lang="en-US" dirty="0"/>
+              <a:t>Review</a:t>
+            </a:r>
+          </a:p>
+        </p:txBody>
+      </p:sp>
+      <p:sp>
+        <p:nvSpPr>
+          <p:cNvPr id="3" name="Question 1"/>
+          <p:cNvSpPr/>
+          <p:nvPr/>
+        </p:nvSpPr>
+        <p:spPr>
+          <a:xfrm>
+            <a:off x="838200" y="1075688"/>
+            <a:ext cx="10515600" cy="1230000"/>
+          </a:xfrm>
+          <a:prstGeom prst="roundRect">
+            <a:avLst>
+              <a:gd name="adj" fmla="val 4000"/>
+            </a:avLst>
+          </a:prstGeom>
+          <a:solidFill>
+            <a:srgbClr val="F2F6FC"/>
+          </a:solidFill>
+          <a:ln w="19050">
+            <a:solidFill>
+              <a:schemeClr val="accent1"/>
+            </a:solidFill>
+          </a:ln>
+        </p:spPr>
+        <p:txBody>
+          <a:bodyPr lIns="228600" tIns="182880" rIns="228600" bIns="91440" anchor="t">
+            <a:normAutofit/>
+          </a:bodyPr>
+          <a:lstStyle/>
+          <a:p>
+            <a:pPr marL="0" indent="0">
+              <a:buNone/>
+            </a:pPr>
+            <a:r>
+              <a:rPr lang="en-US" b="1">
+                <a:solidFill>
+                  <a:srgbClr val="4472C4"/>
+                </a:solidFill>
+              </a:rPr>
+              <a:t>1   </a:t>
+            </a:r>
+            <a:r>
+              <a:rPr lang="en-US" b="1"/>
+              <a:t>How do we bin a continuous variable?</a:t>
+            </a:r>
+            <a:endParaRPr lang="en-US" b="1" dirty="0"/>
+          </a:p>
+        </p:txBody>
+      </p:sp>
+      <p:sp>
+        <p:nvSpPr>
+          <p:cNvPr id="4" name="Answer 1"/>
+          <p:cNvSpPr txBox="1"/>
+          <p:nvPr/>
+        </p:nvSpPr>
+        <p:spPr>
+          <a:xfrm>
+            <a:off x="1066800" y="1655688"/>
+            <a:ext cx="10058400" cy="558560"/>
+          </a:xfrm>
+          <a:prstGeom prst="rect">
+            <a:avLst/>
+          </a:prstGeom>
+          <a:noFill/>
+        </p:spPr>
+        <p:txBody>
+          <a:bodyPr wrap="square" lIns="0" tIns="0" rIns="0" bIns="0">
+            <a:normAutofit/>
+          </a:bodyPr>
+          <a:lstStyle/>
+          <a:p>
+            <a:pPr marL="0" indent="0">
+              <a:buNone/>
+            </a:pPr>
+            <a:r>
+              <a:rPr lang="en-US">
+                <a:solidFill>
+                  <a:srgbClr val="C00000"/>
+                </a:solidFill>
+              </a:rPr>
+              <a:t>Divide the range into K non-overlapping intervals of equal width, then count how many fall in each.</a:t>
+            </a:r>
+            <a:endParaRPr lang="en-US" dirty="0">
+              <a:solidFill>
+                <a:srgbClr val="C00000"/>
+              </a:solidFill>
+            </a:endParaRPr>
+          </a:p>
+        </p:txBody>
+      </p:sp>
+      <p:sp>
+        <p:nvSpPr>
+          <p:cNvPr id="5" name="Question 2"/>
+          <p:cNvSpPr/>
+          <p:nvPr/>
+        </p:nvSpPr>
+        <p:spPr>
+          <a:xfrm>
+            <a:off x="838200" y="2385688"/>
+            <a:ext cx="10515600" cy="1230000"/>
+          </a:xfrm>
+          <a:prstGeom prst="roundRect">
+            <a:avLst>
+              <a:gd name="adj" fmla="val 4000"/>
+            </a:avLst>
+          </a:prstGeom>
+          <a:solidFill>
+            <a:srgbClr val="F2F6FC"/>
+          </a:solidFill>
+          <a:ln w="19050">
+            <a:solidFill>
+              <a:schemeClr val="accent1"/>
+            </a:solidFill>
+          </a:ln>
+        </p:spPr>
+        <p:txBody>
+          <a:bodyPr lIns="228600" tIns="182880" rIns="228600" bIns="91440" anchor="t">
+            <a:normAutofit/>
+          </a:bodyPr>
+          <a:lstStyle/>
+          <a:p>
+            <a:pPr marL="0" indent="0">
+              <a:buNone/>
+            </a:pPr>
+            <a:r>
+              <a:rPr lang="en-US" b="1">
+                <a:solidFill>
+                  <a:srgbClr val="4472C4"/>
+                </a:solidFill>
+              </a:rPr>
+              <a:t>2   </a:t>
+            </a:r>
+            <a:r>
+              <a:rPr lang="en-US" b="1"/>
+              <a:t>Which graphs do we use for a qualitative variable?</a:t>
+            </a:r>
+            <a:endParaRPr lang="en-US" b="1" dirty="0"/>
+          </a:p>
+        </p:txBody>
+      </p:sp>
+      <p:sp>
+        <p:nvSpPr>
+          <p:cNvPr id="6" name="Answer 2"/>
+          <p:cNvSpPr txBox="1"/>
+          <p:nvPr/>
+        </p:nvSpPr>
+        <p:spPr>
+          <a:xfrm>
+            <a:off x="1066800" y="2965688"/>
+            <a:ext cx="10058400" cy="558560"/>
+          </a:xfrm>
+          <a:prstGeom prst="rect">
+            <a:avLst/>
+          </a:prstGeom>
+          <a:noFill/>
+        </p:spPr>
+        <p:txBody>
+          <a:bodyPr wrap="square" lIns="0" tIns="0" rIns="0" bIns="0">
+            <a:normAutofit/>
+          </a:bodyPr>
+          <a:lstStyle/>
+          <a:p>
+            <a:pPr marL="0" indent="0">
+              <a:buNone/>
+            </a:pPr>
+            <a:r>
+              <a:rPr lang="en-US" sz="1600">
+                <a:solidFill>
+                  <a:srgbClr val="C00000"/>
+                </a:solidFill>
+              </a:rPr>
+              <a:t>Bar graphs, pie charts, and Pareto charts.</a:t>
+            </a:r>
+            <a:endParaRPr lang="en-US" sz="1600" dirty="0">
+              <a:solidFill>
+                <a:srgbClr val="C00000"/>
+              </a:solidFill>
+            </a:endParaRPr>
+          </a:p>
+        </p:txBody>
+      </p:sp>
+      <p:sp>
+        <p:nvSpPr>
+          <p:cNvPr id="7" name="Question 3"/>
+          <p:cNvSpPr/>
+          <p:nvPr/>
+        </p:nvSpPr>
+        <p:spPr>
+          <a:xfrm>
+            <a:off x="838200" y="3695688"/>
+            <a:ext cx="10515600" cy="1230000"/>
+          </a:xfrm>
+          <a:prstGeom prst="roundRect">
+            <a:avLst>
+              <a:gd name="adj" fmla="val 4000"/>
+            </a:avLst>
+          </a:prstGeom>
+          <a:solidFill>
+            <a:srgbClr val="F2F6FC"/>
+          </a:solidFill>
+          <a:ln w="19050">
+            <a:solidFill>
+              <a:schemeClr val="accent1"/>
+            </a:solidFill>
+          </a:ln>
+        </p:spPr>
+        <p:txBody>
+          <a:bodyPr lIns="228600" tIns="182880" rIns="228600" bIns="91440" anchor="t">
+            <a:normAutofit/>
+          </a:bodyPr>
+          <a:lstStyle/>
+          <a:p>
+            <a:pPr marL="0" indent="0">
+              <a:buNone/>
+            </a:pPr>
+            <a:r>
+              <a:rPr lang="en-US" b="1">
+                <a:solidFill>
+                  <a:srgbClr val="4472C4"/>
+                </a:solidFill>
+              </a:rPr>
+              <a:t>3   </a:t>
+            </a:r>
+            <a:r>
+              <a:rPr lang="en-US" b="1"/>
+              <a:t>Which graphs do we use for a quantitative variable?</a:t>
+            </a:r>
+            <a:endParaRPr lang="en-US" b="1" dirty="0"/>
+          </a:p>
+        </p:txBody>
+      </p:sp>
+      <p:sp>
+        <p:nvSpPr>
+          <p:cNvPr id="8" name="Answer 3"/>
+          <p:cNvSpPr txBox="1"/>
+          <p:nvPr/>
+        </p:nvSpPr>
+        <p:spPr>
+          <a:xfrm>
+            <a:off x="1066800" y="4275688"/>
+            <a:ext cx="10058400" cy="558560"/>
+          </a:xfrm>
+          <a:prstGeom prst="rect">
+            <a:avLst/>
+          </a:prstGeom>
+          <a:noFill/>
+        </p:spPr>
+        <p:txBody>
+          <a:bodyPr wrap="square" lIns="0" tIns="0" rIns="0" bIns="0">
+            <a:normAutofit/>
+          </a:bodyPr>
+          <a:lstStyle/>
+          <a:p>
+            <a:pPr marL="0" indent="0">
+              <a:buNone/>
+            </a:pPr>
+            <a:r>
+              <a:rPr lang="en-US" sz="1600">
+                <a:solidFill>
+                  <a:srgbClr val="C00000"/>
+                </a:solidFill>
+              </a:rPr>
+              <a:t>Dot plots, stem and leaf plots, and histograms – today's topic.</a:t>
+            </a:r>
+            <a:endParaRPr lang="en-US" sz="1600" dirty="0">
+              <a:solidFill>
+                <a:srgbClr val="C00000"/>
+              </a:solidFill>
+            </a:endParaRPr>
+          </a:p>
+        </p:txBody>
+      </p:sp>
+      <p:sp>
+        <p:nvSpPr>
+          <p:cNvPr id="9" name="Question 4"/>
+          <p:cNvSpPr/>
+          <p:nvPr/>
+        </p:nvSpPr>
+        <p:spPr>
+          <a:xfrm>
+            <a:off x="838200" y="5005688"/>
+            <a:ext cx="10515600" cy="1230000"/>
+          </a:xfrm>
+          <a:prstGeom prst="roundRect">
+            <a:avLst>
+              <a:gd name="adj" fmla="val 4000"/>
+            </a:avLst>
+          </a:prstGeom>
+          <a:solidFill>
+            <a:srgbClr val="F2F6FC"/>
+          </a:solidFill>
+          <a:ln w="19050">
+            <a:solidFill>
+              <a:schemeClr val="accent1"/>
+            </a:solidFill>
+          </a:ln>
+        </p:spPr>
+        <p:txBody>
+          <a:bodyPr lIns="228600" tIns="182880" rIns="228600" bIns="91440" anchor="t">
+            <a:normAutofit/>
+          </a:bodyPr>
+          <a:lstStyle/>
+          <a:p>
+            <a:pPr marL="0" indent="0">
+              <a:buNone/>
+            </a:pPr>
+            <a:r>
+              <a:rPr lang="en-US" b="1">
+                <a:solidFill>
+                  <a:srgbClr val="4472C4"/>
+                </a:solidFill>
+              </a:rPr>
+              <a:t>4   </a:t>
+            </a:r>
+            <a:r>
+              <a:rPr lang="en-US" b="1"/>
+              <a:t>Why graph the data when we already have the frequency table?</a:t>
+            </a:r>
+            <a:endParaRPr lang="en-US" b="1" dirty="0"/>
+          </a:p>
+        </p:txBody>
+      </p:sp>
+      <p:sp>
+        <p:nvSpPr>
+          <p:cNvPr id="10" name="Answer 4"/>
+          <p:cNvSpPr txBox="1"/>
+          <p:nvPr/>
+        </p:nvSpPr>
+        <p:spPr>
+          <a:xfrm>
+            <a:off x="1066800" y="5585688"/>
+            <a:ext cx="10058400" cy="558560"/>
+          </a:xfrm>
+          <a:prstGeom prst="rect">
+            <a:avLst/>
+          </a:prstGeom>
+          <a:noFill/>
+        </p:spPr>
+        <p:txBody>
+          <a:bodyPr wrap="square" lIns="0" tIns="0" rIns="0" bIns="0">
+            <a:normAutofit/>
+          </a:bodyPr>
+          <a:lstStyle/>
+          <a:p>
+            <a:pPr marL="0" indent="0">
+              <a:buNone/>
+            </a:pPr>
+            <a:r>
+              <a:rPr lang="en-US" sz="1600">
+                <a:solidFill>
+                  <a:srgbClr val="C00000"/>
+                </a:solidFill>
+              </a:rPr>
+              <a:t>The graph shows shape, center, and spread at a glance, along with any outliers.</a:t>
+            </a:r>
+            <a:endParaRPr lang="en-US" sz="1600" dirty="0">
+              <a:solidFill>
+                <a:srgbClr val="C00000"/>
+              </a:solidFill>
+            </a:endParaRPr>
+          </a:p>
+        </p:txBody>
+      </p:sp>
+    </p:spTree>
+    <p:extLst>
+      <p:ext uri="{BB962C8B-B14F-4D97-AF65-F5344CB8AC3E}">
+        <p14:creationId xmlns:p14="http://schemas.microsoft.com/office/powerpoint/2010/main" val="1517484012"/>
+      </p:ext>
+    </p:extLst>
+  </p:cSld>
+  <p:clrMapOvr>
+    <a:masterClrMapping/>
+  </p:clrMapOvr>
+  <p:timing>
+    <p:tnLst>
+      <p:par>
+        <p:cTn id="1" dur="indefinite" restart="never" nodeType="tmRoot">
+          <p:childTnLst>
+            <p:seq concurrent="1" nextAc="seek">
+              <p:cTn id="2" dur="indefinite" nodeType="mainSeq">
+                <p:childTnLst>
+                  <p:par>
+                    <p:cTn id="3" fill="hold">
+                      <p:stCondLst>
+                        <p:cond delay="indefinite"/>
+                      </p:stCondLst>
+                      <p:childTnLst>
+                        <p:par>
+                          <p:cTn id="4" fill="hold">
+                            <p:stCondLst>
+                              <p:cond delay="0"/>
+                            </p:stCondLst>
+                            <p:childTnLst>
+                              <p:par>
+                                <p:cTn id="5" presetID="1" presetClass="entr" presetSubtype="0" fill="hold" nodeType="clickEffect">
+                                  <p:stCondLst>
+                                    <p:cond delay="0"/>
+                                  </p:stCondLst>
+                                  <p:childTnLst>
+                                    <p:set>
+                                      <p:cBhvr>
+                                        <p:cTn id="6" dur="1" fill="hold">
+                                          <p:stCondLst>
+                                            <p:cond delay="0"/>
+                                          </p:stCondLst>
+                                        </p:cTn>
+                                        <p:tgtEl>
+                                          <p:spTgt spid="3"/>
+                                        </p:tgtEl>
+                                        <p:attrNameLst>
+                                          <p:attrName>style.visibility</p:attrName>
+                                        </p:attrNameLst>
+                                      </p:cBhvr>
+                                      <p:to>
+                                        <p:strVal val="visible"/>
+                                      </p:to>
+                                    </p:set>
+                                  </p:childTnLst>
+                                </p:cTn>
+                              </p:par>
+                            </p:childTnLst>
+                          </p:cTn>
+                        </p:par>
+                      </p:childTnLst>
+                    </p:cTn>
+                  </p:par>
+                  <p:par>
+                    <p:cTn id="7" fill="hold">
+                      <p:stCondLst>
+                        <p:cond delay="indefinite"/>
+                      </p:stCondLst>
+                      <p:childTnLst>
+                        <p:par>
+                          <p:cTn id="8" fill="hold">
+                            <p:stCondLst>
+                              <p:cond delay="0"/>
+                            </p:stCondLst>
+                            <p:childTnLst>
+                              <p:par>
+                                <p:cTn id="9" presetID="1" presetClass="entr" presetSubtype="0" fill="hold" nodeType="clickEffect">
+                                  <p:stCondLst>
+                                    <p:cond delay="0"/>
+                                  </p:stCondLst>
+                                  <p:childTnLst>
+                                    <p:set>
+                                      <p:cBhvr>
+                                        <p:cTn id="10" dur="1" fill="hold">
+                                          <p:stCondLst>
+                                            <p:cond delay="0"/>
+                                          </p:stCondLst>
+                                        </p:cTn>
+                                        <p:tgtEl>
+                                          <p:spTgt spid="4"/>
+                                        </p:tgtEl>
+                                        <p:attrNameLst>
+                                          <p:attrName>style.visibility</p:attrName>
+                                        </p:attrNameLst>
+                                      </p:cBhvr>
+                                      <p:to>
+                                        <p:strVal val="visible"/>
+                                      </p:to>
+                                    </p:set>
+                                  </p:childTnLst>
+                                </p:cTn>
+                              </p:par>
+                            </p:childTnLst>
+                          </p:cTn>
+                        </p:par>
+                      </p:childTnLst>
+                    </p:cTn>
+                  </p:par>
+                  <p:par>
+                    <p:cTn id="11" fill="hold">
+                      <p:stCondLst>
+                        <p:cond delay="indefinite"/>
+                      </p:stCondLst>
+                      <p:childTnLst>
+                        <p:par>
+                          <p:cTn id="12" fill="hold">
+                            <p:stCondLst>
+                              <p:cond delay="0"/>
+                            </p:stCondLst>
+                            <p:childTnLst>
+                              <p:par>
+                                <p:cTn id="13" presetID="1" presetClass="entr" presetSubtype="0" fill="hold" nodeType="clickEffect">
+                                  <p:stCondLst>
+                                    <p:cond delay="0"/>
+                                  </p:stCondLst>
+                                  <p:childTnLst>
+                                    <p:set>
+                                      <p:cBhvr>
+                                        <p:cTn id="14" dur="1" fill="hold">
+                                          <p:stCondLst>
+                                            <p:cond delay="0"/>
+                                          </p:stCondLst>
+                                        </p:cTn>
+                                        <p:tgtEl>
+                                          <p:spTgt spid="5"/>
+                                        </p:tgtEl>
+                                        <p:attrNameLst>
+                                          <p:attrName>style.visibility</p:attrName>
+                                        </p:attrNameLst>
+                                      </p:cBhvr>
+                                      <p:to>
+                                        <p:strVal val="visible"/>
+                                      </p:to>
+                                    </p:set>
+                                  </p:childTnLst>
+                                </p:cTn>
+                              </p:par>
+                            </p:childTnLst>
+                          </p:cTn>
+                        </p:par>
+                      </p:childTnLst>
+                    </p:cTn>
+                  </p:par>
+                  <p:par>
+                    <p:cTn id="15" fill="hold">
+                      <p:stCondLst>
+                        <p:cond delay="indefinite"/>
+                      </p:stCondLst>
+                      <p:childTnLst>
+                        <p:par>
+                          <p:cTn id="16" fill="hold">
+                            <p:stCondLst>
+                              <p:cond delay="0"/>
+                            </p:stCondLst>
+                            <p:childTnLst>
+                              <p:par>
+                                <p:cTn id="17" presetID="1" presetClass="entr" presetSubtype="0" fill="hold" nodeType="clickEffect">
+                                  <p:stCondLst>
+                                    <p:cond delay="0"/>
+                                  </p:stCondLst>
+                                  <p:childTnLst>
+                                    <p:set>
+                                      <p:cBhvr>
+                                        <p:cTn id="18" dur="1" fill="hold">
+                                          <p:stCondLst>
+                                            <p:cond delay="0"/>
+                                          </p:stCondLst>
+                                        </p:cTn>
+                                        <p:tgtEl>
+                                          <p:spTgt spid="6"/>
+                                        </p:tgtEl>
+                                        <p:attrNameLst>
+                                          <p:attrName>style.visibility</p:attrName>
+                                        </p:attrNameLst>
+                                      </p:cBhvr>
+                                      <p:to>
+                                        <p:strVal val="visible"/>
+                                      </p:to>
+                                    </p:set>
+                                  </p:childTnLst>
+                                </p:cTn>
+                              </p:par>
+                            </p:childTnLst>
+                          </p:cTn>
+                        </p:par>
+                      </p:childTnLst>
+                    </p:cTn>
+                  </p:par>
+                  <p:par>
+                    <p:cTn id="19" fill="hold">
+                      <p:stCondLst>
+                        <p:cond delay="indefinite"/>
+                      </p:stCondLst>
+                      <p:childTnLst>
+                        <p:par>
+                          <p:cTn id="20" fill="hold">
+                            <p:stCondLst>
+                              <p:cond delay="0"/>
+                            </p:stCondLst>
+                            <p:childTnLst>
+                              <p:par>
+                                <p:cTn id="21" presetID="1" presetClass="entr" presetSubtype="0" fill="hold" nodeType="clickEffect">
+                                  <p:stCondLst>
+                                    <p:cond delay="0"/>
+                                  </p:stCondLst>
+                                  <p:childTnLst>
+                                    <p:set>
+                                      <p:cBhvr>
+                                        <p:cTn id="22" dur="1" fill="hold">
+                                          <p:stCondLst>
+                                            <p:cond delay="0"/>
+                                          </p:stCondLst>
+                                        </p:cTn>
+                                        <p:tgtEl>
+                                          <p:spTgt spid="7"/>
+                                        </p:tgtEl>
+                                        <p:attrNameLst>
+                                          <p:attrName>style.visibility</p:attrName>
+                                        </p:attrNameLst>
+                                      </p:cBhvr>
+                                      <p:to>
+                                        <p:strVal val="visible"/>
+                                      </p:to>
+                                    </p:set>
+                                  </p:childTnLst>
+                                </p:cTn>
+                              </p:par>
+                            </p:childTnLst>
+                          </p:cTn>
+                        </p:par>
+                      </p:childTnLst>
+                    </p:cTn>
+                  </p:par>
+                  <p:par>
+                    <p:cTn id="23" fill="hold">
+                      <p:stCondLst>
+                        <p:cond delay="indefinite"/>
+                      </p:stCondLst>
+                      <p:childTnLst>
+                        <p:par>
+                          <p:cTn id="24" fill="hold">
+                            <p:stCondLst>
+                              <p:cond delay="0"/>
+                            </p:stCondLst>
+                            <p:childTnLst>
+                              <p:par>
+                                <p:cTn id="25" presetID="1" presetClass="entr" presetSubtype="0" fill="hold" nodeType="clickEffect">
+                                  <p:stCondLst>
+                                    <p:cond delay="0"/>
+                                  </p:stCondLst>
+                                  <p:childTnLst>
+                                    <p:set>
+                                      <p:cBhvr>
+                                        <p:cTn id="26" dur="1" fill="hold">
+                                          <p:stCondLst>
+                                            <p:cond delay="0"/>
+                                          </p:stCondLst>
+                                        </p:cTn>
+                                        <p:tgtEl>
+                                          <p:spTgt spid="8"/>
+                                        </p:tgtEl>
+                                        <p:attrNameLst>
+                                          <p:attrName>style.visibility</p:attrName>
+                                        </p:attrNameLst>
+                                      </p:cBhvr>
+                                      <p:to>
+                                        <p:strVal val="visible"/>
+                                      </p:to>
+                                    </p:set>
+                                  </p:childTnLst>
+                                </p:cTn>
+                              </p:par>
+                            </p:childTnLst>
+                          </p:cTn>
+                        </p:par>
+                      </p:childTnLst>
+                    </p:cTn>
+                  </p:par>
+                  <p:par>
+                    <p:cTn id="27" fill="hold">
+                      <p:stCondLst>
+                        <p:cond delay="indefinite"/>
+                      </p:stCondLst>
+                      <p:childTnLst>
+                        <p:par>
+                          <p:cTn id="28" fill="hold">
+                            <p:stCondLst>
+                              <p:cond delay="0"/>
+                            </p:stCondLst>
+                            <p:childTnLst>
+                              <p:par>
+                                <p:cTn id="29" presetID="1" presetClass="entr" presetSubtype="0" fill="hold" nodeType="clickEffect">
+                                  <p:stCondLst>
+                                    <p:cond delay="0"/>
+                                  </p:stCondLst>
+                                  <p:childTnLst>
+                                    <p:set>
+                                      <p:cBhvr>
+                                        <p:cTn id="30" dur="1" fill="hold">
+                                          <p:stCondLst>
+                                            <p:cond delay="0"/>
+                                          </p:stCondLst>
+                                        </p:cTn>
+                                        <p:tgtEl>
+                                          <p:spTgt spid="9"/>
+                                        </p:tgtEl>
+                                        <p:attrNameLst>
+                                          <p:attrName>style.visibility</p:attrName>
+                                        </p:attrNameLst>
+                                      </p:cBhvr>
+                                      <p:to>
+                                        <p:strVal val="visible"/>
+                                      </p:to>
+                                    </p:set>
+                                  </p:childTnLst>
+                                </p:cTn>
+                              </p:par>
+                            </p:childTnLst>
+                          </p:cTn>
+                        </p:par>
+                      </p:childTnLst>
+                    </p:cTn>
+                  </p:par>
+                  <p:par>
+                    <p:cTn id="31" fill="hold">
+                      <p:stCondLst>
+                        <p:cond delay="indefinite"/>
+                      </p:stCondLst>
+                      <p:childTnLst>
+                        <p:par>
+                          <p:cTn id="32" fill="hold">
+                            <p:stCondLst>
+                              <p:cond delay="0"/>
+                            </p:stCondLst>
+                            <p:childTnLst>
+                              <p:par>
+                                <p:cTn id="33" presetID="1" presetClass="entr" presetSubtype="0" fill="hold" nodeType="clickEffect">
+                                  <p:stCondLst>
+                                    <p:cond delay="0"/>
+                                  </p:stCondLst>
+                                  <p:childTnLst>
+                                    <p:set>
+                                      <p:cBhvr>
+                                        <p:cTn id="34" dur="1" fill="hold">
+                                          <p:stCondLst>
+                                            <p:cond delay="0"/>
+                                          </p:stCondLst>
+                                        </p:cTn>
+                                        <p:tgtEl>
+                                          <p:spTgt spid="10"/>
+                                        </p:tgtEl>
+                                        <p:attrNameLst>
+                                          <p:attrName>style.visibility</p:attrName>
+                                        </p:attrNameLst>
+                                      </p:cBhvr>
+                                      <p:to>
+                                        <p:strVal val="visible"/>
+                                      </p:to>
+                                    </p:set>
+                                  </p:childTnLst>
+                                </p:cTn>
+                              </p:par>
+                            </p:childTnLst>
+                          </p:cTn>
+                        </p:par>
+                      </p:childTnLst>
+                    </p:cTn>
+                  </p:par>
+                </p:childTnLst>
+              </p:cTn>
+              <p:prevCondLst>
+                <p:cond evt="onPrev" delay="0">
+                  <p:tgtEl>
+                    <p:sldTgt/>
+                  </p:tgtEl>
+                </p:cond>
+              </p:prevCondLst>
+              <p:nextCondLst>
+                <p:cond evt="onNext" delay="0">
+                  <p:tgtEl>
+                    <p:sldTgt/>
+                  </p:tgtEl>
+                </p:cond>
+              </p:nextCondLst>
+            </p:seq>
+          </p:childTnLst>
+        </p:cTn>
+      </p:par>
+    </p:tnLst>
+  </p:timing>
+</p:sld>
+</file>
+
+<file path=ppt/slides/slide30.xml><?xml version="1.0" encoding="utf-8"?>
 <p:sld xmlns:a="http://schemas.openxmlformats.org/drawingml/2006/main" xmlns:r="http://schemas.openxmlformats.org/officeDocument/2006/relationships" xmlns:p="http://schemas.openxmlformats.org/presentationml/2006/main">
   <p:cSld>
     <p:spTree>
@@ -12731,7 +12575,7 @@
 </p:sld>
 </file>
 
-<file path=ppt/slides/slide32.xml><?xml version="1.0" encoding="utf-8"?>
+<file path=ppt/slides/slide31.xml><?xml version="1.0" encoding="utf-8"?>
 <p:sld xmlns:a="http://schemas.openxmlformats.org/drawingml/2006/main" xmlns:r="http://schemas.openxmlformats.org/officeDocument/2006/relationships" xmlns:p="http://schemas.openxmlformats.org/presentationml/2006/main">
   <p:cSld>
     <p:spTree>
@@ -12791,7 +12635,7 @@
 </p:sld>
 </file>
 
-<file path=ppt/slides/slide33.xml><?xml version="1.0" encoding="utf-8"?>
+<file path=ppt/slides/slide32.xml><?xml version="1.0" encoding="utf-8"?>
 <p:sld xmlns:a="http://schemas.openxmlformats.org/drawingml/2006/main" xmlns:r="http://schemas.openxmlformats.org/officeDocument/2006/relationships" xmlns:p="http://schemas.openxmlformats.org/presentationml/2006/main">
   <p:cSld>
     <p:spTree>
@@ -13199,7 +13043,7 @@
 </p:sld>
 </file>
 
-<file path=ppt/slides/slide34.xml><?xml version="1.0" encoding="utf-8"?>
+<file path=ppt/slides/slide33.xml><?xml version="1.0" encoding="utf-8"?>
 <p:sld xmlns:a="http://schemas.openxmlformats.org/drawingml/2006/main" xmlns:r="http://schemas.openxmlformats.org/officeDocument/2006/relationships" xmlns:p="http://schemas.openxmlformats.org/presentationml/2006/main">
   <p:cSld>
     <p:spTree>
@@ -13768,7 +13612,7 @@
 </p:sld>
 </file>
 
-<file path=ppt/slides/slide35.xml><?xml version="1.0" encoding="utf-8"?>
+<file path=ppt/slides/slide34.xml><?xml version="1.0" encoding="utf-8"?>
 <p:sld xmlns:a="http://schemas.openxmlformats.org/drawingml/2006/main" xmlns:r="http://schemas.openxmlformats.org/officeDocument/2006/relationships" xmlns:p="http://schemas.openxmlformats.org/presentationml/2006/main">
   <p:cSld>
     <p:spTree>
@@ -14683,7 +14527,7 @@
 </p:sld>
 </file>
 
-<file path=ppt/slides/slide36.xml><?xml version="1.0" encoding="utf-8"?>
+<file path=ppt/slides/slide35.xml><?xml version="1.0" encoding="utf-8"?>
 <p:sld xmlns:a="http://schemas.openxmlformats.org/drawingml/2006/main" xmlns:r="http://schemas.openxmlformats.org/officeDocument/2006/relationships" xmlns:p="http://schemas.openxmlformats.org/presentationml/2006/main">
   <p:cSld>
     <p:spTree>

</xml_diff>